<commit_message>
docs: add Hackathon Technical Master Guide & Defense Cheat Sheet (Hackathon_Technical_Master_Guide.md)
</commit_message>
<xml_diff>
--- a/TechX_Enterprise_AI_SIH_Presentation.pptx
+++ b/TechX_Enterprise_AI_SIH_Presentation.pptx
@@ -5,18 +5,18 @@
     <p:sldMasterId id="2147483648" r:id="rId1"/>
   </p:sldMasterIdLst>
   <p:sldIdLst>
-    <p:sldId id="256" r:id="rId7"/>
-    <p:sldId id="257" r:id="rId8"/>
-    <p:sldId id="258" r:id="rId9"/>
-    <p:sldId id="259" r:id="rId10"/>
-    <p:sldId id="260" r:id="rId11"/>
-    <p:sldId id="261" r:id="rId12"/>
-    <p:sldId id="262" r:id="rId13"/>
-    <p:sldId id="263" r:id="rId14"/>
-    <p:sldId id="264" r:id="rId15"/>
-    <p:sldId id="265" r:id="rId16"/>
+    <p:sldId id="256" r:id="rId2"/>
+    <p:sldId id="257" r:id="rId3"/>
+    <p:sldId id="258" r:id="rId4"/>
+    <p:sldId id="259" r:id="rId5"/>
+    <p:sldId id="260" r:id="rId6"/>
+    <p:sldId id="261" r:id="rId7"/>
+    <p:sldId id="262" r:id="rId8"/>
+    <p:sldId id="263" r:id="rId9"/>
+    <p:sldId id="264" r:id="rId10"/>
+    <p:sldId id="265" r:id="rId11"/>
   </p:sldIdLst>
-  <p:sldSz cx="12191695" cy="6858000" type="screen4x3"/>
+  <p:sldSz cx="12192000" cy="6858000"/>
   <p:notesSz cx="6858000" cy="9144000"/>
   <p:defaultTextStyle>
     <a:defPPr>
@@ -113,7 +113,99 @@
       </a:defRPr>
     </a:lvl9pPr>
   </p:defaultTextStyle>
+  <p:extLst>
+    <p:ext uri="{EFAFB233-063F-42B5-8137-9DF3F51BA10A}">
+      <p15:sldGuideLst xmlns:p15="http://schemas.microsoft.com/office/powerpoint/2012/main">
+        <p15:guide id="1" orient="horz" pos="2160">
+          <p15:clr>
+            <a:srgbClr val="A4A3A4"/>
+          </p15:clr>
+        </p15:guide>
+        <p15:guide id="2" pos="2880">
+          <p15:clr>
+            <a:srgbClr val="A4A3A4"/>
+          </p15:clr>
+        </p15:guide>
+      </p15:sldGuideLst>
+    </p:ext>
+  </p:extLst>
 </p:presentation>
+</file>
+
+<file path=ppt/changesInfos/changesInfo1.xml><?xml version="1.0" encoding="utf-8"?>
+<pc:chgInfo xmlns:a="http://schemas.openxmlformats.org/drawingml/2006/main" xmlns:r="http://schemas.openxmlformats.org/officeDocument/2006/relationships" xmlns:ac="http://schemas.microsoft.com/office/drawing/2013/main/command" xmlns:pc="http://schemas.microsoft.com/office/powerpoint/2013/main/command">
+  <pc:docChgLst>
+    <pc:chgData name="vabi3388@outlook.com" userId="8b4ef784b944ea01" providerId="LiveId" clId="{B63B23B7-1E7A-4F06-B302-3E3D7BAAD350}"/>
+    <pc:docChg chg="custSel modSld">
+      <pc:chgData name="vabi3388@outlook.com" userId="8b4ef784b944ea01" providerId="LiveId" clId="{B63B23B7-1E7A-4F06-B302-3E3D7BAAD350}" dt="2026-09-15T16:15:39.859" v="231" actId="20577"/>
+      <pc:docMkLst>
+        <pc:docMk/>
+      </pc:docMkLst>
+      <pc:sldChg chg="modSp mod">
+        <pc:chgData name="vabi3388@outlook.com" userId="8b4ef784b944ea01" providerId="LiveId" clId="{B63B23B7-1E7A-4F06-B302-3E3D7BAAD350}" dt="2026-09-15T16:15:39.859" v="231" actId="20577"/>
+        <pc:sldMkLst>
+          <pc:docMk/>
+          <pc:sldMk cId="0" sldId="256"/>
+        </pc:sldMkLst>
+        <pc:spChg chg="mod">
+          <ac:chgData name="vabi3388@outlook.com" userId="8b4ef784b944ea01" providerId="LiveId" clId="{B63B23B7-1E7A-4F06-B302-3E3D7BAAD350}" dt="2026-09-15T16:15:39.859" v="231" actId="20577"/>
+          <ac:spMkLst>
+            <pc:docMk/>
+            <pc:sldMk cId="0" sldId="256"/>
+            <ac:spMk id="3" creationId="{00000000-0000-0000-0000-000000000000}"/>
+          </ac:spMkLst>
+        </pc:spChg>
+      </pc:sldChg>
+      <pc:sldChg chg="modSp mod">
+        <pc:chgData name="vabi3388@outlook.com" userId="8b4ef784b944ea01" providerId="LiveId" clId="{B63B23B7-1E7A-4F06-B302-3E3D7BAAD350}" dt="2026-09-15T16:12:55.513" v="2" actId="207"/>
+        <pc:sldMkLst>
+          <pc:docMk/>
+          <pc:sldMk cId="0" sldId="264"/>
+        </pc:sldMkLst>
+        <pc:spChg chg="mod">
+          <ac:chgData name="vabi3388@outlook.com" userId="8b4ef784b944ea01" providerId="LiveId" clId="{B63B23B7-1E7A-4F06-B302-3E3D7BAAD350}" dt="2026-09-15T16:12:41.815" v="0" actId="790"/>
+          <ac:spMkLst>
+            <pc:docMk/>
+            <pc:sldMk cId="0" sldId="264"/>
+            <ac:spMk id="2" creationId="{00000000-0000-0000-0000-000000000000}"/>
+          </ac:spMkLst>
+        </pc:spChg>
+        <pc:spChg chg="mod">
+          <ac:chgData name="vabi3388@outlook.com" userId="8b4ef784b944ea01" providerId="LiveId" clId="{B63B23B7-1E7A-4F06-B302-3E3D7BAAD350}" dt="2026-09-15T16:12:41.815" v="0" actId="790"/>
+          <ac:spMkLst>
+            <pc:docMk/>
+            <pc:sldMk cId="0" sldId="264"/>
+            <ac:spMk id="3" creationId="{00000000-0000-0000-0000-000000000000}"/>
+          </ac:spMkLst>
+        </pc:spChg>
+        <pc:spChg chg="mod">
+          <ac:chgData name="vabi3388@outlook.com" userId="8b4ef784b944ea01" providerId="LiveId" clId="{B63B23B7-1E7A-4F06-B302-3E3D7BAAD350}" dt="2026-09-15T16:12:50.512" v="1" actId="207"/>
+          <ac:spMkLst>
+            <pc:docMk/>
+            <pc:sldMk cId="0" sldId="264"/>
+            <ac:spMk id="4" creationId="{00000000-0000-0000-0000-000000000000}"/>
+          </ac:spMkLst>
+        </pc:spChg>
+        <pc:spChg chg="mod">
+          <ac:chgData name="vabi3388@outlook.com" userId="8b4ef784b944ea01" providerId="LiveId" clId="{B63B23B7-1E7A-4F06-B302-3E3D7BAAD350}" dt="2026-09-15T16:12:41.815" v="0" actId="790"/>
+          <ac:spMkLst>
+            <pc:docMk/>
+            <pc:sldMk cId="0" sldId="264"/>
+            <ac:spMk id="5" creationId="{00000000-0000-0000-0000-000000000000}"/>
+          </ac:spMkLst>
+        </pc:spChg>
+        <pc:spChg chg="mod">
+          <ac:chgData name="vabi3388@outlook.com" userId="8b4ef784b944ea01" providerId="LiveId" clId="{B63B23B7-1E7A-4F06-B302-3E3D7BAAD350}" dt="2026-09-15T16:12:55.513" v="2" actId="207"/>
+          <ac:spMkLst>
+            <pc:docMk/>
+            <pc:sldMk cId="0" sldId="264"/>
+            <ac:spMk id="6" creationId="{00000000-0000-0000-0000-000000000000}"/>
+          </ac:spMkLst>
+        </pc:spChg>
+      </pc:sldChg>
+    </pc:docChg>
+  </pc:docChgLst>
+</pc:chgInfo>
 </file>
 
 <file path=ppt/slideLayouts/slideLayout1.xml><?xml version="1.0" encoding="utf-8"?>
@@ -154,10 +246,9 @@
           <a:lstStyle/>
           <a:p>
             <a:r>
-              <a:rPr lang="en-US" smtClean="0"/>
+              <a:rPr lang="en-US"/>
               <a:t>Click to edit Master title style</a:t>
             </a:r>
-            <a:endParaRPr lang="en-US"/>
           </a:p>
         </p:txBody>
       </p:sp>
@@ -273,10 +364,9 @@
           </a:lstStyle>
           <a:p>
             <a:r>
-              <a:rPr lang="en-US" smtClean="0"/>
+              <a:rPr lang="en-US"/>
               <a:t>Click to edit Master subtitle style</a:t>
             </a:r>
-            <a:endParaRPr lang="en-US"/>
           </a:p>
         </p:txBody>
       </p:sp>
@@ -297,7 +387,7 @@
           <a:p>
             <a:fld id="{5BCAD085-E8A6-8845-BD4E-CB4CCA059FC4}" type="datetimeFigureOut">
               <a:rPr lang="en-US" smtClean="0"/>
-              <a:t>1/27/13</a:t>
+              <a:t>9/15/2026</a:t>
             </a:fld>
             <a:endParaRPr lang="en-US"/>
           </a:p>
@@ -391,10 +481,9 @@
           <a:lstStyle/>
           <a:p>
             <a:r>
-              <a:rPr lang="en-US" smtClean="0"/>
+              <a:rPr lang="en-US"/>
               <a:t>Click to edit Master title style</a:t>
             </a:r>
-            <a:endParaRPr lang="en-US"/>
           </a:p>
         </p:txBody>
       </p:sp>
@@ -415,38 +504,37 @@
           <a:p>
             <a:pPr lvl="0"/>
             <a:r>
-              <a:rPr lang="en-US" smtClean="0"/>
+              <a:rPr lang="en-US"/>
               <a:t>Click to edit Master text styles</a:t>
             </a:r>
           </a:p>
           <a:p>
             <a:pPr lvl="1"/>
             <a:r>
-              <a:rPr lang="en-US" smtClean="0"/>
+              <a:rPr lang="en-US"/>
               <a:t>Second level</a:t>
             </a:r>
           </a:p>
           <a:p>
             <a:pPr lvl="2"/>
             <a:r>
-              <a:rPr lang="en-US" smtClean="0"/>
+              <a:rPr lang="en-US"/>
               <a:t>Third level</a:t>
             </a:r>
           </a:p>
           <a:p>
             <a:pPr lvl="3"/>
             <a:r>
-              <a:rPr lang="en-US" smtClean="0"/>
+              <a:rPr lang="en-US"/>
               <a:t>Fourth level</a:t>
             </a:r>
           </a:p>
           <a:p>
             <a:pPr lvl="4"/>
             <a:r>
-              <a:rPr lang="en-US" smtClean="0"/>
+              <a:rPr lang="en-US"/>
               <a:t>Fifth level</a:t>
             </a:r>
-            <a:endParaRPr lang="en-US"/>
           </a:p>
         </p:txBody>
       </p:sp>
@@ -467,7 +555,7 @@
           <a:p>
             <a:fld id="{5BCAD085-E8A6-8845-BD4E-CB4CCA059FC4}" type="datetimeFigureOut">
               <a:rPr lang="en-US" smtClean="0"/>
-              <a:t>1/27/13</a:t>
+              <a:t>9/15/2026</a:t>
             </a:fld>
             <a:endParaRPr lang="en-US"/>
           </a:p>
@@ -566,10 +654,9 @@
           <a:lstStyle/>
           <a:p>
             <a:r>
-              <a:rPr lang="en-US" smtClean="0"/>
+              <a:rPr lang="en-US"/>
               <a:t>Click to edit Master title style</a:t>
             </a:r>
-            <a:endParaRPr lang="en-US"/>
           </a:p>
         </p:txBody>
       </p:sp>
@@ -595,38 +682,37 @@
           <a:p>
             <a:pPr lvl="0"/>
             <a:r>
-              <a:rPr lang="en-US" smtClean="0"/>
+              <a:rPr lang="en-US"/>
               <a:t>Click to edit Master text styles</a:t>
             </a:r>
           </a:p>
           <a:p>
             <a:pPr lvl="1"/>
             <a:r>
-              <a:rPr lang="en-US" smtClean="0"/>
+              <a:rPr lang="en-US"/>
               <a:t>Second level</a:t>
             </a:r>
           </a:p>
           <a:p>
             <a:pPr lvl="2"/>
             <a:r>
-              <a:rPr lang="en-US" smtClean="0"/>
+              <a:rPr lang="en-US"/>
               <a:t>Third level</a:t>
             </a:r>
           </a:p>
           <a:p>
             <a:pPr lvl="3"/>
             <a:r>
-              <a:rPr lang="en-US" smtClean="0"/>
+              <a:rPr lang="en-US"/>
               <a:t>Fourth level</a:t>
             </a:r>
           </a:p>
           <a:p>
             <a:pPr lvl="4"/>
             <a:r>
-              <a:rPr lang="en-US" smtClean="0"/>
+              <a:rPr lang="en-US"/>
               <a:t>Fifth level</a:t>
             </a:r>
-            <a:endParaRPr lang="en-US"/>
           </a:p>
         </p:txBody>
       </p:sp>
@@ -647,7 +733,7 @@
           <a:p>
             <a:fld id="{5BCAD085-E8A6-8845-BD4E-CB4CCA059FC4}" type="datetimeFigureOut">
               <a:rPr lang="en-US" smtClean="0"/>
-              <a:t>1/27/13</a:t>
+              <a:t>9/15/2026</a:t>
             </a:fld>
             <a:endParaRPr lang="en-US"/>
           </a:p>
@@ -741,10 +827,9 @@
           <a:lstStyle/>
           <a:p>
             <a:r>
-              <a:rPr lang="en-US" smtClean="0"/>
+              <a:rPr lang="en-US"/>
               <a:t>Click to edit Master title style</a:t>
             </a:r>
-            <a:endParaRPr lang="en-US"/>
           </a:p>
         </p:txBody>
       </p:sp>
@@ -765,38 +850,37 @@
           <a:p>
             <a:pPr lvl="0"/>
             <a:r>
-              <a:rPr lang="en-US" smtClean="0"/>
+              <a:rPr lang="en-US"/>
               <a:t>Click to edit Master text styles</a:t>
             </a:r>
           </a:p>
           <a:p>
             <a:pPr lvl="1"/>
             <a:r>
-              <a:rPr lang="en-US" smtClean="0"/>
+              <a:rPr lang="en-US"/>
               <a:t>Second level</a:t>
             </a:r>
           </a:p>
           <a:p>
             <a:pPr lvl="2"/>
             <a:r>
-              <a:rPr lang="en-US" smtClean="0"/>
+              <a:rPr lang="en-US"/>
               <a:t>Third level</a:t>
             </a:r>
           </a:p>
           <a:p>
             <a:pPr lvl="3"/>
             <a:r>
-              <a:rPr lang="en-US" smtClean="0"/>
+              <a:rPr lang="en-US"/>
               <a:t>Fourth level</a:t>
             </a:r>
           </a:p>
           <a:p>
             <a:pPr lvl="4"/>
             <a:r>
-              <a:rPr lang="en-US" smtClean="0"/>
+              <a:rPr lang="en-US"/>
               <a:t>Fifth level</a:t>
             </a:r>
-            <a:endParaRPr lang="en-US"/>
           </a:p>
         </p:txBody>
       </p:sp>
@@ -817,7 +901,7 @@
           <a:p>
             <a:fld id="{5BCAD085-E8A6-8845-BD4E-CB4CCA059FC4}" type="datetimeFigureOut">
               <a:rPr lang="en-US" smtClean="0"/>
-              <a:t>1/27/13</a:t>
+              <a:t>9/15/2026</a:t>
             </a:fld>
             <a:endParaRPr lang="en-US"/>
           </a:p>
@@ -920,10 +1004,9 @@
           </a:lstStyle>
           <a:p>
             <a:r>
-              <a:rPr lang="en-US" smtClean="0"/>
+              <a:rPr lang="en-US"/>
               <a:t>Click to edit Master title style</a:t>
             </a:r>
-            <a:endParaRPr lang="en-US"/>
           </a:p>
         </p:txBody>
       </p:sp>
@@ -1040,7 +1123,7 @@
           <a:p>
             <a:pPr lvl="0"/>
             <a:r>
-              <a:rPr lang="en-US" smtClean="0"/>
+              <a:rPr lang="en-US"/>
               <a:t>Click to edit Master text styles</a:t>
             </a:r>
           </a:p>
@@ -1063,7 +1146,7 @@
           <a:p>
             <a:fld id="{5BCAD085-E8A6-8845-BD4E-CB4CCA059FC4}" type="datetimeFigureOut">
               <a:rPr lang="en-US" smtClean="0"/>
-              <a:t>1/27/13</a:t>
+              <a:t>9/15/2026</a:t>
             </a:fld>
             <a:endParaRPr lang="en-US"/>
           </a:p>
@@ -1157,10 +1240,9 @@
           <a:lstStyle/>
           <a:p>
             <a:r>
-              <a:rPr lang="en-US" smtClean="0"/>
+              <a:rPr lang="en-US"/>
               <a:t>Click to edit Master title style</a:t>
             </a:r>
-            <a:endParaRPr lang="en-US"/>
           </a:p>
         </p:txBody>
       </p:sp>
@@ -1214,38 +1296,37 @@
           <a:p>
             <a:pPr lvl="0"/>
             <a:r>
-              <a:rPr lang="en-US" smtClean="0"/>
+              <a:rPr lang="en-US"/>
               <a:t>Click to edit Master text styles</a:t>
             </a:r>
           </a:p>
           <a:p>
             <a:pPr lvl="1"/>
             <a:r>
-              <a:rPr lang="en-US" smtClean="0"/>
+              <a:rPr lang="en-US"/>
               <a:t>Second level</a:t>
             </a:r>
           </a:p>
           <a:p>
             <a:pPr lvl="2"/>
             <a:r>
-              <a:rPr lang="en-US" smtClean="0"/>
+              <a:rPr lang="en-US"/>
               <a:t>Third level</a:t>
             </a:r>
           </a:p>
           <a:p>
             <a:pPr lvl="3"/>
             <a:r>
-              <a:rPr lang="en-US" smtClean="0"/>
+              <a:rPr lang="en-US"/>
               <a:t>Fourth level</a:t>
             </a:r>
           </a:p>
           <a:p>
             <a:pPr lvl="4"/>
             <a:r>
-              <a:rPr lang="en-US" smtClean="0"/>
+              <a:rPr lang="en-US"/>
               <a:t>Fifth level</a:t>
             </a:r>
-            <a:endParaRPr lang="en-US"/>
           </a:p>
         </p:txBody>
       </p:sp>
@@ -1299,38 +1380,37 @@
           <a:p>
             <a:pPr lvl="0"/>
             <a:r>
-              <a:rPr lang="en-US" smtClean="0"/>
+              <a:rPr lang="en-US"/>
               <a:t>Click to edit Master text styles</a:t>
             </a:r>
           </a:p>
           <a:p>
             <a:pPr lvl="1"/>
             <a:r>
-              <a:rPr lang="en-US" smtClean="0"/>
+              <a:rPr lang="en-US"/>
               <a:t>Second level</a:t>
             </a:r>
           </a:p>
           <a:p>
             <a:pPr lvl="2"/>
             <a:r>
-              <a:rPr lang="en-US" smtClean="0"/>
+              <a:rPr lang="en-US"/>
               <a:t>Third level</a:t>
             </a:r>
           </a:p>
           <a:p>
             <a:pPr lvl="3"/>
             <a:r>
-              <a:rPr lang="en-US" smtClean="0"/>
+              <a:rPr lang="en-US"/>
               <a:t>Fourth level</a:t>
             </a:r>
           </a:p>
           <a:p>
             <a:pPr lvl="4"/>
             <a:r>
-              <a:rPr lang="en-US" smtClean="0"/>
+              <a:rPr lang="en-US"/>
               <a:t>Fifth level</a:t>
             </a:r>
-            <a:endParaRPr lang="en-US"/>
           </a:p>
         </p:txBody>
       </p:sp>
@@ -1351,7 +1431,7 @@
           <a:p>
             <a:fld id="{5BCAD085-E8A6-8845-BD4E-CB4CCA059FC4}" type="datetimeFigureOut">
               <a:rPr lang="en-US" smtClean="0"/>
-              <a:t>1/27/13</a:t>
+              <a:t>9/15/2026</a:t>
             </a:fld>
             <a:endParaRPr lang="en-US"/>
           </a:p>
@@ -1449,10 +1529,9 @@
           </a:lstStyle>
           <a:p>
             <a:r>
-              <a:rPr lang="en-US" smtClean="0"/>
+              <a:rPr lang="en-US"/>
               <a:t>Click to edit Master title style</a:t>
             </a:r>
-            <a:endParaRPr lang="en-US"/>
           </a:p>
         </p:txBody>
       </p:sp>
@@ -1515,7 +1594,7 @@
           <a:p>
             <a:pPr lvl="0"/>
             <a:r>
-              <a:rPr lang="en-US" smtClean="0"/>
+              <a:rPr lang="en-US"/>
               <a:t>Click to edit Master text styles</a:t>
             </a:r>
           </a:p>
@@ -1571,38 +1650,37 @@
           <a:p>
             <a:pPr lvl="0"/>
             <a:r>
-              <a:rPr lang="en-US" smtClean="0"/>
+              <a:rPr lang="en-US"/>
               <a:t>Click to edit Master text styles</a:t>
             </a:r>
           </a:p>
           <a:p>
             <a:pPr lvl="1"/>
             <a:r>
-              <a:rPr lang="en-US" smtClean="0"/>
+              <a:rPr lang="en-US"/>
               <a:t>Second level</a:t>
             </a:r>
           </a:p>
           <a:p>
             <a:pPr lvl="2"/>
             <a:r>
-              <a:rPr lang="en-US" smtClean="0"/>
+              <a:rPr lang="en-US"/>
               <a:t>Third level</a:t>
             </a:r>
           </a:p>
           <a:p>
             <a:pPr lvl="3"/>
             <a:r>
-              <a:rPr lang="en-US" smtClean="0"/>
+              <a:rPr lang="en-US"/>
               <a:t>Fourth level</a:t>
             </a:r>
           </a:p>
           <a:p>
             <a:pPr lvl="4"/>
             <a:r>
-              <a:rPr lang="en-US" smtClean="0"/>
+              <a:rPr lang="en-US"/>
               <a:t>Fifth level</a:t>
             </a:r>
-            <a:endParaRPr lang="en-US"/>
           </a:p>
         </p:txBody>
       </p:sp>
@@ -1665,7 +1743,7 @@
           <a:p>
             <a:pPr lvl="0"/>
             <a:r>
-              <a:rPr lang="en-US" smtClean="0"/>
+              <a:rPr lang="en-US"/>
               <a:t>Click to edit Master text styles</a:t>
             </a:r>
           </a:p>
@@ -1721,38 +1799,37 @@
           <a:p>
             <a:pPr lvl="0"/>
             <a:r>
-              <a:rPr lang="en-US" smtClean="0"/>
+              <a:rPr lang="en-US"/>
               <a:t>Click to edit Master text styles</a:t>
             </a:r>
           </a:p>
           <a:p>
             <a:pPr lvl="1"/>
             <a:r>
-              <a:rPr lang="en-US" smtClean="0"/>
+              <a:rPr lang="en-US"/>
               <a:t>Second level</a:t>
             </a:r>
           </a:p>
           <a:p>
             <a:pPr lvl="2"/>
             <a:r>
-              <a:rPr lang="en-US" smtClean="0"/>
+              <a:rPr lang="en-US"/>
               <a:t>Third level</a:t>
             </a:r>
           </a:p>
           <a:p>
             <a:pPr lvl="3"/>
             <a:r>
-              <a:rPr lang="en-US" smtClean="0"/>
+              <a:rPr lang="en-US"/>
               <a:t>Fourth level</a:t>
             </a:r>
           </a:p>
           <a:p>
             <a:pPr lvl="4"/>
             <a:r>
-              <a:rPr lang="en-US" smtClean="0"/>
+              <a:rPr lang="en-US"/>
               <a:t>Fifth level</a:t>
             </a:r>
-            <a:endParaRPr lang="en-US"/>
           </a:p>
         </p:txBody>
       </p:sp>
@@ -1773,7 +1850,7 @@
           <a:p>
             <a:fld id="{5BCAD085-E8A6-8845-BD4E-CB4CCA059FC4}" type="datetimeFigureOut">
               <a:rPr lang="en-US" smtClean="0"/>
-              <a:t>1/27/13</a:t>
+              <a:t>9/15/2026</a:t>
             </a:fld>
             <a:endParaRPr lang="en-US"/>
           </a:p>
@@ -1867,10 +1944,9 @@
           <a:lstStyle/>
           <a:p>
             <a:r>
-              <a:rPr lang="en-US" smtClean="0"/>
+              <a:rPr lang="en-US"/>
               <a:t>Click to edit Master title style</a:t>
             </a:r>
-            <a:endParaRPr lang="en-US"/>
           </a:p>
         </p:txBody>
       </p:sp>
@@ -1891,7 +1967,7 @@
           <a:p>
             <a:fld id="{5BCAD085-E8A6-8845-BD4E-CB4CCA059FC4}" type="datetimeFigureOut">
               <a:rPr lang="en-US" smtClean="0"/>
-              <a:t>1/27/13</a:t>
+              <a:t>9/15/2026</a:t>
             </a:fld>
             <a:endParaRPr lang="en-US"/>
           </a:p>
@@ -1986,7 +2062,7 @@
           <a:p>
             <a:fld id="{5BCAD085-E8A6-8845-BD4E-CB4CCA059FC4}" type="datetimeFigureOut">
               <a:rPr lang="en-US" smtClean="0"/>
-              <a:t>1/27/13</a:t>
+              <a:t>9/15/2026</a:t>
             </a:fld>
             <a:endParaRPr lang="en-US"/>
           </a:p>
@@ -2089,10 +2165,9 @@
           </a:lstStyle>
           <a:p>
             <a:r>
-              <a:rPr lang="en-US" smtClean="0"/>
+              <a:rPr lang="en-US"/>
               <a:t>Click to edit Master title style</a:t>
             </a:r>
-            <a:endParaRPr lang="en-US"/>
           </a:p>
         </p:txBody>
       </p:sp>
@@ -2146,38 +2221,37 @@
           <a:p>
             <a:pPr lvl="0"/>
             <a:r>
-              <a:rPr lang="en-US" smtClean="0"/>
+              <a:rPr lang="en-US"/>
               <a:t>Click to edit Master text styles</a:t>
             </a:r>
           </a:p>
           <a:p>
             <a:pPr lvl="1"/>
             <a:r>
-              <a:rPr lang="en-US" smtClean="0"/>
+              <a:rPr lang="en-US"/>
               <a:t>Second level</a:t>
             </a:r>
           </a:p>
           <a:p>
             <a:pPr lvl="2"/>
             <a:r>
-              <a:rPr lang="en-US" smtClean="0"/>
+              <a:rPr lang="en-US"/>
               <a:t>Third level</a:t>
             </a:r>
           </a:p>
           <a:p>
             <a:pPr lvl="3"/>
             <a:r>
-              <a:rPr lang="en-US" smtClean="0"/>
+              <a:rPr lang="en-US"/>
               <a:t>Fourth level</a:t>
             </a:r>
           </a:p>
           <a:p>
             <a:pPr lvl="4"/>
             <a:r>
-              <a:rPr lang="en-US" smtClean="0"/>
+              <a:rPr lang="en-US"/>
               <a:t>Fifth level</a:t>
             </a:r>
-            <a:endParaRPr lang="en-US"/>
           </a:p>
         </p:txBody>
       </p:sp>
@@ -2240,7 +2314,7 @@
           <a:p>
             <a:pPr lvl="0"/>
             <a:r>
-              <a:rPr lang="en-US" smtClean="0"/>
+              <a:rPr lang="en-US"/>
               <a:t>Click to edit Master text styles</a:t>
             </a:r>
           </a:p>
@@ -2263,7 +2337,7 @@
           <a:p>
             <a:fld id="{5BCAD085-E8A6-8845-BD4E-CB4CCA059FC4}" type="datetimeFigureOut">
               <a:rPr lang="en-US" smtClean="0"/>
-              <a:t>1/27/13</a:t>
+              <a:t>9/15/2026</a:t>
             </a:fld>
             <a:endParaRPr lang="en-US"/>
           </a:p>
@@ -2366,10 +2440,9 @@
           </a:lstStyle>
           <a:p>
             <a:r>
-              <a:rPr lang="en-US" smtClean="0"/>
+              <a:rPr lang="en-US"/>
               <a:t>Click to edit Master title style</a:t>
             </a:r>
-            <a:endParaRPr lang="en-US"/>
           </a:p>
         </p:txBody>
       </p:sp>
@@ -2493,7 +2566,7 @@
           <a:p>
             <a:pPr lvl="0"/>
             <a:r>
-              <a:rPr lang="en-US" smtClean="0"/>
+              <a:rPr lang="en-US"/>
               <a:t>Click to edit Master text styles</a:t>
             </a:r>
           </a:p>
@@ -2516,7 +2589,7 @@
           <a:p>
             <a:fld id="{5BCAD085-E8A6-8845-BD4E-CB4CCA059FC4}" type="datetimeFigureOut">
               <a:rPr lang="en-US" smtClean="0"/>
-              <a:t>1/27/13</a:t>
+              <a:t>9/15/2026</a:t>
             </a:fld>
             <a:endParaRPr lang="en-US"/>
           </a:p>
@@ -2625,10 +2698,9 @@
           <a:lstStyle/>
           <a:p>
             <a:r>
-              <a:rPr lang="en-US" smtClean="0"/>
+              <a:rPr lang="en-US"/>
               <a:t>Click to edit Master title style</a:t>
             </a:r>
-            <a:endParaRPr lang="en-US"/>
           </a:p>
         </p:txBody>
       </p:sp>
@@ -2659,38 +2731,37 @@
           <a:p>
             <a:pPr lvl="0"/>
             <a:r>
-              <a:rPr lang="en-US" smtClean="0"/>
+              <a:rPr lang="en-US"/>
               <a:t>Click to edit Master text styles</a:t>
             </a:r>
           </a:p>
           <a:p>
             <a:pPr lvl="1"/>
             <a:r>
-              <a:rPr lang="en-US" smtClean="0"/>
+              <a:rPr lang="en-US"/>
               <a:t>Second level</a:t>
             </a:r>
           </a:p>
           <a:p>
             <a:pPr lvl="2"/>
             <a:r>
-              <a:rPr lang="en-US" smtClean="0"/>
+              <a:rPr lang="en-US"/>
               <a:t>Third level</a:t>
             </a:r>
           </a:p>
           <a:p>
             <a:pPr lvl="3"/>
             <a:r>
-              <a:rPr lang="en-US" smtClean="0"/>
+              <a:rPr lang="en-US"/>
               <a:t>Fourth level</a:t>
             </a:r>
           </a:p>
           <a:p>
             <a:pPr lvl="4"/>
             <a:r>
-              <a:rPr lang="en-US" smtClean="0"/>
+              <a:rPr lang="en-US"/>
               <a:t>Fifth level</a:t>
             </a:r>
-            <a:endParaRPr lang="en-US"/>
           </a:p>
         </p:txBody>
       </p:sp>
@@ -2729,7 +2800,7 @@
           <a:p>
             <a:fld id="{5BCAD085-E8A6-8845-BD4E-CB4CCA059FC4}" type="datetimeFigureOut">
               <a:rPr lang="en-US" smtClean="0"/>
-              <a:t>1/27/13</a:t>
+              <a:t>9/15/2026</a:t>
             </a:fld>
             <a:endParaRPr lang="en-US"/>
           </a:p>
@@ -3088,7 +3159,7 @@
 </file>
 
 <file path=ppt/slides/slide1.xml><?xml version="1.0" encoding="utf-8"?>
-<p:sld xmlns:a="http://schemas.openxmlformats.org/drawingml/2006/main" xmlns:p="http://schemas.openxmlformats.org/presentationml/2006/main" xmlns:r="http://schemas.openxmlformats.org/officeDocument/2006/relationships">
+<p:sld xmlns:a="http://schemas.openxmlformats.org/drawingml/2006/main" xmlns:r="http://schemas.openxmlformats.org/officeDocument/2006/relationships" xmlns:p="http://schemas.openxmlformats.org/presentationml/2006/main">
   <p:cSld>
     <p:spTree>
       <p:nvGrpSpPr>
@@ -3096,7 +3167,14 @@
         <p:cNvGrpSpPr/>
         <p:nvPr/>
       </p:nvGrpSpPr>
-      <p:grpSpPr/>
+      <p:grpSpPr>
+        <a:xfrm>
+          <a:off x="0" y="0"/>
+          <a:ext cx="0" cy="0"/>
+          <a:chOff x="0" y="0"/>
+          <a:chExt cx="0" cy="0"/>
+        </a:xfrm>
+      </p:grpSpPr>
       <p:sp>
         <p:nvSpPr>
           <p:cNvPr id="2" name="Rectangle 1"/>
@@ -3201,44 +3279,26 @@
           </a:fontRef>
         </p:style>
         <p:txBody>
-          <a:bodyPr rtlCol="0" anchor="ctr" lIns="274320" tIns="274320"/>
+          <a:bodyPr lIns="274320" tIns="274320" rtlCol="0" anchor="ctr"/>
           <a:lstStyle/>
           <a:p>
             <a:pPr algn="ctr"/>
+            <a:endParaRPr dirty="0"/>
           </a:p>
           <a:p>
             <a:pPr>
-              <a:defRPr b="1" sz="1300">
+              <a:defRPr sz="1300" b="1">
                 <a:solidFill>
                   <a:srgbClr val="C8102E"/>
                 </a:solidFill>
               </a:defRPr>
             </a:pPr>
             <a:r>
-              <a:t>Problem Statement ID: </a:t>
-            </a:r>
-            <a:r>
-              <a:rPr b="0">
-                <a:solidFill>
-                  <a:srgbClr val="0F172A"/>
-                </a:solidFill>
-              </a:rPr>
-              <a:t>SIH2026-AI-042</a:t>
-            </a:r>
-          </a:p>
-          <a:p>
-            <a:pPr>
-              <a:defRPr b="1" sz="1300">
-                <a:solidFill>
-                  <a:srgbClr val="C8102E"/>
-                </a:solidFill>
-              </a:defRPr>
-            </a:pPr>
-            <a:r>
+              <a:rPr dirty="0"/>
               <a:t>Problem Statement Title: </a:t>
             </a:r>
             <a:r>
-              <a:rPr b="0">
+              <a:rPr b="0" dirty="0">
                 <a:solidFill>
                   <a:srgbClr val="0F172A"/>
                 </a:solidFill>
@@ -3248,17 +3308,18 @@
           </a:p>
           <a:p>
             <a:pPr>
-              <a:defRPr b="1" sz="1300">
+              <a:defRPr sz="1300" b="1">
                 <a:solidFill>
                   <a:srgbClr val="C8102E"/>
                 </a:solidFill>
               </a:defRPr>
             </a:pPr>
             <a:r>
+              <a:rPr dirty="0"/>
               <a:t>Theme / Domain: </a:t>
             </a:r>
             <a:r>
-              <a:rPr b="0">
+              <a:rPr b="0" dirty="0">
                 <a:solidFill>
                   <a:srgbClr val="0F172A"/>
                 </a:solidFill>
@@ -3268,17 +3329,18 @@
           </a:p>
           <a:p>
             <a:pPr>
-              <a:defRPr b="1" sz="1300">
+              <a:defRPr sz="1300" b="1">
                 <a:solidFill>
                   <a:srgbClr val="C8102E"/>
                 </a:solidFill>
               </a:defRPr>
             </a:pPr>
             <a:r>
+              <a:rPr dirty="0"/>
               <a:t>PS Category: </a:t>
             </a:r>
             <a:r>
-              <a:rPr b="0">
+              <a:rPr b="0" dirty="0">
                 <a:solidFill>
                   <a:srgbClr val="0F172A"/>
                 </a:solidFill>
@@ -3288,83 +3350,192 @@
           </a:p>
           <a:p>
             <a:pPr>
-              <a:defRPr b="1" sz="1300">
+              <a:defRPr sz="1300" b="1">
                 <a:solidFill>
                   <a:srgbClr val="C8102E"/>
                 </a:solidFill>
               </a:defRPr>
             </a:pPr>
             <a:r>
-              <a:t>Team ID: </a:t>
-            </a:r>
-            <a:r>
-              <a:rPr b="0">
+              <a:rPr dirty="0"/>
+              <a:t>Team Name: </a:t>
+            </a:r>
+            <a:r>
+              <a:rPr b="0" dirty="0">
                 <a:solidFill>
                   <a:srgbClr val="0F172A"/>
                 </a:solidFill>
               </a:rPr>
-              <a:t>73869</a:t>
+              <a:t>Tech</a:t>
+            </a:r>
+            <a:r>
+              <a:rPr lang="en-US" b="0" dirty="0">
+                <a:solidFill>
+                  <a:srgbClr val="0F172A"/>
+                </a:solidFill>
+              </a:rPr>
+              <a:t>ies </a:t>
             </a:r>
           </a:p>
           <a:p>
             <a:pPr>
-              <a:defRPr b="1" sz="1300">
+              <a:defRPr sz="1300" b="1">
                 <a:solidFill>
                   <a:srgbClr val="C8102E"/>
                 </a:solidFill>
               </a:defRPr>
             </a:pPr>
             <a:r>
-              <a:t>Team Name: </a:t>
-            </a:r>
-            <a:r>
-              <a:rPr b="0">
+              <a:rPr dirty="0"/>
+              <a:t>Team Leader Name: </a:t>
+            </a:r>
+            <a:r>
+              <a:rPr dirty="0">
                 <a:solidFill>
                   <a:srgbClr val="0F172A"/>
                 </a:solidFill>
               </a:rPr>
-              <a:t>TechX Innovators</a:t>
-            </a:r>
+              <a:t>Abhijit </a:t>
+            </a:r>
+            <a:r>
+              <a:rPr lang="en-US" dirty="0">
+                <a:solidFill>
+                  <a:srgbClr val="0F172A"/>
+                </a:solidFill>
+              </a:rPr>
+              <a:t>V</a:t>
+            </a:r>
+            <a:endParaRPr b="0" dirty="0">
+              <a:solidFill>
+                <a:srgbClr val="0F172A"/>
+              </a:solidFill>
+            </a:endParaRPr>
           </a:p>
           <a:p>
             <a:pPr>
-              <a:defRPr b="1" sz="1300">
+              <a:defRPr sz="1300" b="1">
                 <a:solidFill>
                   <a:srgbClr val="C8102E"/>
                 </a:solidFill>
               </a:defRPr>
             </a:pPr>
             <a:r>
-              <a:t>Team Leader Name: </a:t>
-            </a:r>
-            <a:r>
-              <a:rPr b="0">
-                <a:solidFill>
-                  <a:srgbClr val="0F172A"/>
+              <a:rPr dirty="0"/>
+              <a:t>Team Members:</a:t>
+            </a:r>
+            <a:r>
+              <a:rPr lang="en-US" dirty="0"/>
+              <a:t> </a:t>
+            </a:r>
+            <a:r>
+              <a:rPr lang="en-US" dirty="0" err="1">
+                <a:solidFill>
+                  <a:schemeClr val="tx1"/>
                 </a:solidFill>
               </a:rPr>
-              <a:t>Abhijit Sharma</a:t>
+              <a:t>Amudala</a:t>
+            </a:r>
+            <a:r>
+              <a:rPr lang="en-US" dirty="0">
+                <a:solidFill>
+                  <a:schemeClr val="tx1"/>
+                </a:solidFill>
+              </a:rPr>
+              <a:t> Rahul Kumar</a:t>
             </a:r>
           </a:p>
           <a:p>
             <a:pPr>
-              <a:defRPr b="1" sz="1300">
+              <a:defRPr sz="1300" b="1">
                 <a:solidFill>
                   <a:srgbClr val="C8102E"/>
                 </a:solidFill>
               </a:defRPr>
             </a:pPr>
             <a:r>
-              <a:t>Team Members: </a:t>
-            </a:r>
-            <a:r>
-              <a:rPr b="0">
-                <a:solidFill>
-                  <a:srgbClr val="0F172A"/>
+              <a:rPr lang="en-US" dirty="0">
+                <a:solidFill>
+                  <a:schemeClr val="tx1"/>
                 </a:solidFill>
               </a:rPr>
-              <a:t>Abhijit Sharma, Data Engineer, UI/UX Lead, Backend Architect, QA Auditor</a:t>
-            </a:r>
+              <a:t>                              Sheik </a:t>
+            </a:r>
+            <a:r>
+              <a:rPr lang="en-US" dirty="0" err="1">
+                <a:solidFill>
+                  <a:schemeClr val="tx1"/>
+                </a:solidFill>
+              </a:rPr>
+              <a:t>shahul</a:t>
+            </a:r>
+            <a:r>
+              <a:rPr lang="en-US" dirty="0">
+                <a:solidFill>
+                  <a:schemeClr val="tx1"/>
+                </a:solidFill>
+              </a:rPr>
+              <a:t> </a:t>
+            </a:r>
+            <a:r>
+              <a:rPr lang="en-US" dirty="0" err="1">
+                <a:solidFill>
+                  <a:schemeClr val="tx1"/>
+                </a:solidFill>
+              </a:rPr>
+              <a:t>hameed</a:t>
+            </a:r>
+            <a:endParaRPr lang="en-US" dirty="0">
+              <a:solidFill>
+                <a:schemeClr val="tx1"/>
+              </a:solidFill>
+            </a:endParaRPr>
+          </a:p>
+          <a:p>
+            <a:pPr>
+              <a:defRPr sz="1300" b="1">
+                <a:solidFill>
+                  <a:srgbClr val="C8102E"/>
+                </a:solidFill>
+              </a:defRPr>
+            </a:pPr>
+            <a:r>
+              <a:rPr lang="en-US" dirty="0">
+                <a:solidFill>
+                  <a:schemeClr val="tx1"/>
+                </a:solidFill>
+              </a:rPr>
+              <a:t>                              Santhosh S</a:t>
+            </a:r>
+          </a:p>
+          <a:p>
+            <a:pPr>
+              <a:defRPr sz="1300" b="1">
+                <a:solidFill>
+                  <a:srgbClr val="C8102E"/>
+                </a:solidFill>
+              </a:defRPr>
+            </a:pPr>
+            <a:r>
+              <a:rPr lang="en-US" dirty="0">
+                <a:solidFill>
+                  <a:schemeClr val="tx1"/>
+                </a:solidFill>
+              </a:rPr>
+              <a:t>                              Sai </a:t>
+            </a:r>
+            <a:r>
+              <a:rPr lang="en-US">
+                <a:solidFill>
+                  <a:schemeClr val="tx1"/>
+                </a:solidFill>
+              </a:rPr>
+              <a:t>prasad P</a:t>
+            </a:r>
+            <a:endParaRPr dirty="0">
+              <a:solidFill>
+                <a:schemeClr val="tx1"/>
+              </a:solidFill>
+            </a:endParaRPr>
           </a:p>
         </p:txBody>
       </p:sp>
@@ -3406,7 +3577,7 @@
           </a:fontRef>
         </p:style>
         <p:txBody>
-          <a:bodyPr rtlCol="0" anchor="ctr" tIns="1371600"/>
+          <a:bodyPr tIns="1371600" rtlCol="0" anchor="ctr"/>
           <a:lstStyle/>
           <a:p>
             <a:pPr algn="ctr">
@@ -3480,6 +3651,7 @@
           <a:lstStyle/>
           <a:p>
             <a:pPr algn="ctr"/>
+            <a:endParaRPr/>
           </a:p>
         </p:txBody>
       </p:sp>
@@ -3492,7 +3664,7 @@
 </file>
 
 <file path=ppt/slides/slide10.xml><?xml version="1.0" encoding="utf-8"?>
-<p:sld xmlns:a="http://schemas.openxmlformats.org/drawingml/2006/main" xmlns:p="http://schemas.openxmlformats.org/presentationml/2006/main" xmlns:r="http://schemas.openxmlformats.org/officeDocument/2006/relationships">
+<p:sld xmlns:a="http://schemas.openxmlformats.org/drawingml/2006/main" xmlns:r="http://schemas.openxmlformats.org/officeDocument/2006/relationships" xmlns:p="http://schemas.openxmlformats.org/presentationml/2006/main">
   <p:cSld>
     <p:spTree>
       <p:nvGrpSpPr>
@@ -3500,7 +3672,14 @@
         <p:cNvGrpSpPr/>
         <p:nvPr/>
       </p:nvGrpSpPr>
-      <p:grpSpPr/>
+      <p:grpSpPr>
+        <a:xfrm>
+          <a:off x="0" y="0"/>
+          <a:ext cx="0" cy="0"/>
+          <a:chOff x="0" y="0"/>
+          <a:chExt cx="0" cy="0"/>
+        </a:xfrm>
+      </p:grpSpPr>
       <p:sp>
         <p:nvSpPr>
           <p:cNvPr id="2" name="Rectangle 1"/>
@@ -3539,7 +3718,7 @@
           </a:fontRef>
         </p:style>
         <p:txBody>
-          <a:bodyPr rtlCol="0" anchor="ctr" wrap="square" lIns="457200" tIns="228600"/>
+          <a:bodyPr wrap="square" lIns="457200" tIns="228600" rtlCol="0" anchor="ctr"/>
           <a:lstStyle/>
           <a:p>
             <a:pPr algn="l">
@@ -3597,6 +3776,7 @@
           <a:lstStyle/>
           <a:p>
             <a:pPr algn="ctr"/>
+            <a:endParaRPr/>
           </a:p>
         </p:txBody>
       </p:sp>
@@ -3638,14 +3818,15 @@
           </a:fontRef>
         </p:style>
         <p:txBody>
-          <a:bodyPr rtlCol="0" anchor="ctr" lIns="365760" tIns="365760"/>
+          <a:bodyPr lIns="365760" tIns="365760" rtlCol="0" anchor="ctr"/>
           <a:lstStyle/>
           <a:p>
             <a:pPr algn="ctr"/>
+            <a:endParaRPr/>
           </a:p>
           <a:p>
             <a:pPr>
-              <a:defRPr b="1" sz="1500">
+              <a:defRPr sz="1500" b="1">
                 <a:solidFill>
                   <a:srgbClr val="C8102E"/>
                 </a:solidFill>
@@ -3665,7 +3846,7 @@
           </a:p>
           <a:p>
             <a:pPr>
-              <a:defRPr b="1" sz="1500">
+              <a:defRPr sz="1500" b="1">
                 <a:solidFill>
                   <a:srgbClr val="C8102E"/>
                 </a:solidFill>
@@ -3685,7 +3866,7 @@
           </a:p>
           <a:p>
             <a:pPr>
-              <a:defRPr b="1" sz="1500">
+              <a:defRPr sz="1500" b="1">
                 <a:solidFill>
                   <a:srgbClr val="C8102E"/>
                 </a:solidFill>
@@ -3705,7 +3886,7 @@
           </a:p>
           <a:p>
             <a:pPr>
-              <a:defRPr b="1" sz="1500">
+              <a:defRPr sz="1500" b="1">
                 <a:solidFill>
                   <a:srgbClr val="C8102E"/>
                 </a:solidFill>
@@ -3725,7 +3906,7 @@
           </a:p>
           <a:p>
             <a:pPr>
-              <a:defRPr b="1" sz="1500">
+              <a:defRPr sz="1500" b="1">
                 <a:solidFill>
                   <a:srgbClr val="C8102E"/>
                 </a:solidFill>
@@ -3754,7 +3935,7 @@
 </file>
 
 <file path=ppt/slides/slide2.xml><?xml version="1.0" encoding="utf-8"?>
-<p:sld xmlns:a="http://schemas.openxmlformats.org/drawingml/2006/main" xmlns:p="http://schemas.openxmlformats.org/presentationml/2006/main" xmlns:r="http://schemas.openxmlformats.org/officeDocument/2006/relationships">
+<p:sld xmlns:a="http://schemas.openxmlformats.org/drawingml/2006/main" xmlns:r="http://schemas.openxmlformats.org/officeDocument/2006/relationships" xmlns:p="http://schemas.openxmlformats.org/presentationml/2006/main">
   <p:cSld>
     <p:spTree>
       <p:nvGrpSpPr>
@@ -3762,7 +3943,14 @@
         <p:cNvGrpSpPr/>
         <p:nvPr/>
       </p:nvGrpSpPr>
-      <p:grpSpPr/>
+      <p:grpSpPr>
+        <a:xfrm>
+          <a:off x="0" y="0"/>
+          <a:ext cx="0" cy="0"/>
+          <a:chOff x="0" y="0"/>
+          <a:chExt cx="0" cy="0"/>
+        </a:xfrm>
+      </p:grpSpPr>
       <p:sp>
         <p:nvSpPr>
           <p:cNvPr id="2" name="Rectangle 1"/>
@@ -3801,7 +3989,7 @@
           </a:fontRef>
         </p:style>
         <p:txBody>
-          <a:bodyPr rtlCol="0" anchor="ctr" wrap="square" lIns="457200" tIns="228600"/>
+          <a:bodyPr wrap="square" lIns="457200" tIns="228600" rtlCol="0" anchor="ctr"/>
           <a:lstStyle/>
           <a:p>
             <a:pPr algn="l">
@@ -3859,6 +4047,7 @@
           <a:lstStyle/>
           <a:p>
             <a:pPr algn="ctr"/>
+            <a:endParaRPr/>
           </a:p>
         </p:txBody>
       </p:sp>
@@ -3900,14 +4089,15 @@
           </a:fontRef>
         </p:style>
         <p:txBody>
-          <a:bodyPr rtlCol="0" anchor="ctr" lIns="365760" tIns="365760"/>
+          <a:bodyPr lIns="365760" tIns="365760" rtlCol="0" anchor="ctr"/>
           <a:lstStyle/>
           <a:p>
             <a:pPr algn="ctr"/>
+            <a:endParaRPr/>
           </a:p>
           <a:p>
             <a:pPr>
-              <a:defRPr b="1" sz="1500">
+              <a:defRPr sz="1500" b="1">
                 <a:solidFill>
                   <a:srgbClr val="C8102E"/>
                 </a:solidFill>
@@ -3925,10 +4115,16 @@
               <a:t>Business analysts, executives, and managers struggle to write complex SQL queries or joins, creating dependency bottlenecks on data teams.</a:t>
             </a:r>
           </a:p>
-          <a:p/>
+          <a:p>
+            <a:endParaRPr b="0">
+              <a:solidFill>
+                <a:srgbClr val="0F172A"/>
+              </a:solidFill>
+            </a:endParaRPr>
+          </a:p>
           <a:p>
             <a:pPr>
-              <a:defRPr b="1" sz="1500">
+              <a:defRPr sz="1500" b="1">
                 <a:solidFill>
                   <a:srgbClr val="C8102E"/>
                 </a:solidFill>
@@ -3946,10 +4142,16 @@
               <a:t>Building custom BI dashboards and query reports manually takes days or weeks, delaying urgent operational decision-making.</a:t>
             </a:r>
           </a:p>
-          <a:p/>
+          <a:p>
+            <a:endParaRPr b="0">
+              <a:solidFill>
+                <a:srgbClr val="0F172A"/>
+              </a:solidFill>
+            </a:endParaRPr>
+          </a:p>
           <a:p>
             <a:pPr>
-              <a:defRPr b="1" sz="1500">
+              <a:defRPr sz="1500" b="1">
                 <a:solidFill>
                   <a:srgbClr val="C8102E"/>
                 </a:solidFill>
@@ -3967,10 +4169,16 @@
               <a:t>Traditional BI systems obscure generated SQL code, making it difficult for developers and auditors to verify query logic or safety.</a:t>
             </a:r>
           </a:p>
-          <a:p/>
+          <a:p>
+            <a:endParaRPr b="0">
+              <a:solidFill>
+                <a:srgbClr val="0F172A"/>
+              </a:solidFill>
+            </a:endParaRPr>
+          </a:p>
           <a:p>
             <a:pPr>
-              <a:defRPr b="1" sz="1500">
+              <a:defRPr sz="1500" b="1">
                 <a:solidFill>
                   <a:srgbClr val="C8102E"/>
                 </a:solidFill>
@@ -3988,7 +4196,13 @@
               <a:t>Modern enterprises maintain separate SQL relational databases (PostgreSQL/SQLite) and NoSQL document stores (Firestore), requiring fragmented query tools.</a:t>
             </a:r>
           </a:p>
-          <a:p/>
+          <a:p>
+            <a:endParaRPr b="0">
+              <a:solidFill>
+                <a:srgbClr val="0F172A"/>
+              </a:solidFill>
+            </a:endParaRPr>
+          </a:p>
         </p:txBody>
       </p:sp>
     </p:spTree>
@@ -4000,7 +4214,7 @@
 </file>
 
 <file path=ppt/slides/slide3.xml><?xml version="1.0" encoding="utf-8"?>
-<p:sld xmlns:a="http://schemas.openxmlformats.org/drawingml/2006/main" xmlns:p="http://schemas.openxmlformats.org/presentationml/2006/main" xmlns:r="http://schemas.openxmlformats.org/officeDocument/2006/relationships">
+<p:sld xmlns:a="http://schemas.openxmlformats.org/drawingml/2006/main" xmlns:r="http://schemas.openxmlformats.org/officeDocument/2006/relationships" xmlns:p="http://schemas.openxmlformats.org/presentationml/2006/main">
   <p:cSld>
     <p:spTree>
       <p:nvGrpSpPr>
@@ -4008,7 +4222,14 @@
         <p:cNvGrpSpPr/>
         <p:nvPr/>
       </p:nvGrpSpPr>
-      <p:grpSpPr/>
+      <p:grpSpPr>
+        <a:xfrm>
+          <a:off x="0" y="0"/>
+          <a:ext cx="0" cy="0"/>
+          <a:chOff x="0" y="0"/>
+          <a:chExt cx="0" cy="0"/>
+        </a:xfrm>
+      </p:grpSpPr>
       <p:sp>
         <p:nvSpPr>
           <p:cNvPr id="2" name="Rectangle 1"/>
@@ -4047,7 +4268,7 @@
           </a:fontRef>
         </p:style>
         <p:txBody>
-          <a:bodyPr rtlCol="0" anchor="ctr" wrap="square" lIns="457200" tIns="228600"/>
+          <a:bodyPr wrap="square" lIns="457200" tIns="228600" rtlCol="0" anchor="ctr"/>
           <a:lstStyle/>
           <a:p>
             <a:pPr algn="l">
@@ -4105,6 +4326,7 @@
           <a:lstStyle/>
           <a:p>
             <a:pPr algn="ctr"/>
+            <a:endParaRPr/>
           </a:p>
         </p:txBody>
       </p:sp>
@@ -4146,11 +4368,11 @@
           </a:fontRef>
         </p:style>
         <p:txBody>
-          <a:bodyPr rtlCol="0" anchor="ctr" lIns="274320" tIns="274320"/>
+          <a:bodyPr lIns="274320" tIns="274320" rtlCol="0" anchor="ctr"/>
           <a:lstStyle/>
           <a:p>
             <a:pPr algn="ctr">
-              <a:defRPr b="1" sz="1800">
+              <a:defRPr sz="1800" b="1">
                 <a:solidFill>
                   <a:srgbClr val="C8102E"/>
                 </a:solidFill>
@@ -4248,11 +4470,11 @@
           </a:fontRef>
         </p:style>
         <p:txBody>
-          <a:bodyPr rtlCol="0" anchor="ctr" lIns="274320" tIns="274320"/>
+          <a:bodyPr lIns="274320" tIns="274320" rtlCol="0" anchor="ctr"/>
           <a:lstStyle/>
           <a:p>
             <a:pPr algn="ctr">
-              <a:defRPr b="1" sz="1800">
+              <a:defRPr sz="1800" b="1">
                 <a:solidFill>
                   <a:srgbClr val="06B6D4"/>
                 </a:solidFill>
@@ -4321,7 +4543,7 @@
 </file>
 
 <file path=ppt/slides/slide4.xml><?xml version="1.0" encoding="utf-8"?>
-<p:sld xmlns:a="http://schemas.openxmlformats.org/drawingml/2006/main" xmlns:p="http://schemas.openxmlformats.org/presentationml/2006/main" xmlns:r="http://schemas.openxmlformats.org/officeDocument/2006/relationships">
+<p:sld xmlns:a="http://schemas.openxmlformats.org/drawingml/2006/main" xmlns:r="http://schemas.openxmlformats.org/officeDocument/2006/relationships" xmlns:p="http://schemas.openxmlformats.org/presentationml/2006/main">
   <p:cSld>
     <p:spTree>
       <p:nvGrpSpPr>
@@ -4329,7 +4551,14 @@
         <p:cNvGrpSpPr/>
         <p:nvPr/>
       </p:nvGrpSpPr>
-      <p:grpSpPr/>
+      <p:grpSpPr>
+        <a:xfrm>
+          <a:off x="0" y="0"/>
+          <a:ext cx="0" cy="0"/>
+          <a:chOff x="0" y="0"/>
+          <a:chExt cx="0" cy="0"/>
+        </a:xfrm>
+      </p:grpSpPr>
       <p:sp>
         <p:nvSpPr>
           <p:cNvPr id="2" name="Rectangle 1"/>
@@ -4368,7 +4597,7 @@
           </a:fontRef>
         </p:style>
         <p:txBody>
-          <a:bodyPr rtlCol="0" anchor="ctr" wrap="square" lIns="457200" tIns="228600"/>
+          <a:bodyPr wrap="square" lIns="457200" tIns="228600" rtlCol="0" anchor="ctr"/>
           <a:lstStyle/>
           <a:p>
             <a:pPr algn="l">
@@ -4426,6 +4655,7 @@
           <a:lstStyle/>
           <a:p>
             <a:pPr algn="ctr"/>
+            <a:endParaRPr/>
           </a:p>
         </p:txBody>
       </p:sp>
@@ -4467,14 +4697,15 @@
           </a:fontRef>
         </p:style>
         <p:txBody>
-          <a:bodyPr rtlCol="0" anchor="ctr" lIns="365760" tIns="365760"/>
+          <a:bodyPr lIns="365760" tIns="365760" rtlCol="0" anchor="ctr"/>
           <a:lstStyle/>
           <a:p>
             <a:pPr algn="ctr"/>
+            <a:endParaRPr/>
           </a:p>
           <a:p>
             <a:pPr>
-              <a:defRPr b="1" sz="1400">
+              <a:defRPr sz="1400" b="1">
                 <a:solidFill>
                   <a:srgbClr val="C8102E"/>
                 </a:solidFill>
@@ -4494,7 +4725,7 @@
           </a:p>
           <a:p>
             <a:pPr>
-              <a:defRPr b="1" sz="1400">
+              <a:defRPr sz="1400" b="1">
                 <a:solidFill>
                   <a:srgbClr val="C8102E"/>
                 </a:solidFill>
@@ -4514,7 +4745,7 @@
           </a:p>
           <a:p>
             <a:pPr>
-              <a:defRPr b="1" sz="1400">
+              <a:defRPr sz="1400" b="1">
                 <a:solidFill>
                   <a:srgbClr val="C8102E"/>
                 </a:solidFill>
@@ -4534,7 +4765,7 @@
           </a:p>
           <a:p>
             <a:pPr>
-              <a:defRPr b="1" sz="1400">
+              <a:defRPr sz="1400" b="1">
                 <a:solidFill>
                   <a:srgbClr val="C8102E"/>
                 </a:solidFill>
@@ -4554,7 +4785,7 @@
           </a:p>
           <a:p>
             <a:pPr>
-              <a:defRPr b="1" sz="1400">
+              <a:defRPr sz="1400" b="1">
                 <a:solidFill>
                   <a:srgbClr val="C8102E"/>
                 </a:solidFill>
@@ -4583,7 +4814,7 @@
 </file>
 
 <file path=ppt/slides/slide5.xml><?xml version="1.0" encoding="utf-8"?>
-<p:sld xmlns:a="http://schemas.openxmlformats.org/drawingml/2006/main" xmlns:p="http://schemas.openxmlformats.org/presentationml/2006/main" xmlns:r="http://schemas.openxmlformats.org/officeDocument/2006/relationships">
+<p:sld xmlns:a="http://schemas.openxmlformats.org/drawingml/2006/main" xmlns:r="http://schemas.openxmlformats.org/officeDocument/2006/relationships" xmlns:p="http://schemas.openxmlformats.org/presentationml/2006/main">
   <p:cSld>
     <p:spTree>
       <p:nvGrpSpPr>
@@ -4591,7 +4822,14 @@
         <p:cNvGrpSpPr/>
         <p:nvPr/>
       </p:nvGrpSpPr>
-      <p:grpSpPr/>
+      <p:grpSpPr>
+        <a:xfrm>
+          <a:off x="0" y="0"/>
+          <a:ext cx="0" cy="0"/>
+          <a:chOff x="0" y="0"/>
+          <a:chExt cx="0" cy="0"/>
+        </a:xfrm>
+      </p:grpSpPr>
       <p:sp>
         <p:nvSpPr>
           <p:cNvPr id="2" name="Rectangle 1"/>
@@ -4630,7 +4868,7 @@
           </a:fontRef>
         </p:style>
         <p:txBody>
-          <a:bodyPr rtlCol="0" anchor="ctr" wrap="square" lIns="457200" tIns="228600"/>
+          <a:bodyPr wrap="square" lIns="457200" tIns="228600" rtlCol="0" anchor="ctr"/>
           <a:lstStyle/>
           <a:p>
             <a:pPr algn="l">
@@ -4688,6 +4926,7 @@
           <a:lstStyle/>
           <a:p>
             <a:pPr algn="ctr"/>
+            <a:endParaRPr/>
           </a:p>
         </p:txBody>
       </p:sp>
@@ -4729,11 +4968,11 @@
           </a:fontRef>
         </p:style>
         <p:txBody>
-          <a:bodyPr rtlCol="0" anchor="ctr" lIns="274320" tIns="137160"/>
+          <a:bodyPr lIns="274320" tIns="137160" rtlCol="0" anchor="ctr"/>
           <a:lstStyle/>
           <a:p>
             <a:pPr algn="ctr">
-              <a:defRPr b="1" sz="1600">
+              <a:defRPr sz="1600" b="1">
                 <a:solidFill>
                   <a:srgbClr val="06B6D4"/>
                 </a:solidFill>
@@ -4743,7 +4982,7 @@
               <a:t>1. get_schema </a:t>
             </a:r>
             <a:r>
-              <a:rPr b="0" sz="1400">
+              <a:rPr sz="1400" b="0">
                 <a:solidFill>
                   <a:srgbClr val="FFFFFF"/>
                 </a:solidFill>
@@ -4791,11 +5030,11 @@
           </a:fontRef>
         </p:style>
         <p:txBody>
-          <a:bodyPr rtlCol="0" anchor="ctr" lIns="274320" tIns="137160"/>
+          <a:bodyPr lIns="274320" tIns="137160" rtlCol="0" anchor="ctr"/>
           <a:lstStyle/>
           <a:p>
             <a:pPr algn="ctr">
-              <a:defRPr b="1" sz="1600">
+              <a:defRPr sz="1600" b="1">
                 <a:solidFill>
                   <a:srgbClr val="C8102E"/>
                 </a:solidFill>
@@ -4805,7 +5044,7 @@
               <a:t>2. execute_query </a:t>
             </a:r>
             <a:r>
-              <a:rPr b="0" sz="1400">
+              <a:rPr sz="1400" b="0">
                 <a:solidFill>
                   <a:srgbClr val="0F172A"/>
                 </a:solidFill>
@@ -4853,11 +5092,11 @@
           </a:fontRef>
         </p:style>
         <p:txBody>
-          <a:bodyPr rtlCol="0" anchor="ctr" lIns="274320" tIns="137160"/>
+          <a:bodyPr lIns="274320" tIns="137160" rtlCol="0" anchor="ctr"/>
           <a:lstStyle/>
           <a:p>
             <a:pPr algn="ctr">
-              <a:defRPr b="1" sz="1600">
+              <a:defRPr sz="1600" b="1">
                 <a:solidFill>
                   <a:srgbClr val="06B6D4"/>
                 </a:solidFill>
@@ -4867,7 +5106,7 @@
               <a:t>3. generate_chart </a:t>
             </a:r>
             <a:r>
-              <a:rPr b="0" sz="1400">
+              <a:rPr sz="1400" b="0">
                 <a:solidFill>
                   <a:srgbClr val="FFFFFF"/>
                 </a:solidFill>
@@ -4915,11 +5154,11 @@
           </a:fontRef>
         </p:style>
         <p:txBody>
-          <a:bodyPr rtlCol="0" anchor="ctr" lIns="274320" tIns="137160"/>
+          <a:bodyPr lIns="274320" tIns="137160" rtlCol="0" anchor="ctr"/>
           <a:lstStyle/>
           <a:p>
             <a:pPr algn="ctr">
-              <a:defRPr b="1" sz="1600">
+              <a:defRPr sz="1600" b="1">
                 <a:solidFill>
                   <a:srgbClr val="C8102E"/>
                 </a:solidFill>
@@ -4929,7 +5168,7 @@
               <a:t>4. generate_flowchart </a:t>
             </a:r>
             <a:r>
-              <a:rPr b="0" sz="1400">
+              <a:rPr sz="1400" b="0">
                 <a:solidFill>
                   <a:srgbClr val="0F172A"/>
                 </a:solidFill>
@@ -4977,11 +5216,11 @@
           </a:fontRef>
         </p:style>
         <p:txBody>
-          <a:bodyPr rtlCol="0" anchor="ctr" lIns="274320" tIns="137160"/>
+          <a:bodyPr lIns="274320" tIns="137160" rtlCol="0" anchor="ctr"/>
           <a:lstStyle/>
           <a:p>
             <a:pPr algn="ctr">
-              <a:defRPr b="1" sz="1600">
+              <a:defRPr sz="1600" b="1">
                 <a:solidFill>
                   <a:srgbClr val="06B6D4"/>
                 </a:solidFill>
@@ -4991,7 +5230,7 @@
               <a:t>5. explain_data </a:t>
             </a:r>
             <a:r>
-              <a:rPr b="0" sz="1400">
+              <a:rPr sz="1400" b="0">
                 <a:solidFill>
                   <a:srgbClr val="FFFFFF"/>
                 </a:solidFill>
@@ -5010,7 +5249,7 @@
 </file>
 
 <file path=ppt/slides/slide6.xml><?xml version="1.0" encoding="utf-8"?>
-<p:sld xmlns:a="http://schemas.openxmlformats.org/drawingml/2006/main" xmlns:p="http://schemas.openxmlformats.org/presentationml/2006/main" xmlns:r="http://schemas.openxmlformats.org/officeDocument/2006/relationships">
+<p:sld xmlns:a="http://schemas.openxmlformats.org/drawingml/2006/main" xmlns:r="http://schemas.openxmlformats.org/officeDocument/2006/relationships" xmlns:p="http://schemas.openxmlformats.org/presentationml/2006/main">
   <p:cSld>
     <p:spTree>
       <p:nvGrpSpPr>
@@ -5018,7 +5257,14 @@
         <p:cNvGrpSpPr/>
         <p:nvPr/>
       </p:nvGrpSpPr>
-      <p:grpSpPr/>
+      <p:grpSpPr>
+        <a:xfrm>
+          <a:off x="0" y="0"/>
+          <a:ext cx="0" cy="0"/>
+          <a:chOff x="0" y="0"/>
+          <a:chExt cx="0" cy="0"/>
+        </a:xfrm>
+      </p:grpSpPr>
       <p:sp>
         <p:nvSpPr>
           <p:cNvPr id="2" name="Rectangle 1"/>
@@ -5057,7 +5303,7 @@
           </a:fontRef>
         </p:style>
         <p:txBody>
-          <a:bodyPr rtlCol="0" anchor="ctr" wrap="square" lIns="457200" tIns="228600"/>
+          <a:bodyPr wrap="square" lIns="457200" tIns="228600" rtlCol="0" anchor="ctr"/>
           <a:lstStyle/>
           <a:p>
             <a:pPr algn="l">
@@ -5115,6 +5361,7 @@
           <a:lstStyle/>
           <a:p>
             <a:pPr algn="ctr"/>
+            <a:endParaRPr/>
           </a:p>
         </p:txBody>
       </p:sp>
@@ -5156,11 +5403,11 @@
           </a:fontRef>
         </p:style>
         <p:txBody>
-          <a:bodyPr rtlCol="0" anchor="ctr" lIns="182880" tIns="182880"/>
+          <a:bodyPr lIns="182880" tIns="182880" rtlCol="0" anchor="ctr"/>
           <a:lstStyle/>
           <a:p>
             <a:pPr algn="ctr">
-              <a:defRPr b="1" sz="1600">
+              <a:defRPr sz="1600" b="1">
                 <a:solidFill>
                   <a:srgbClr val="C8102E"/>
                 </a:solidFill>
@@ -5222,11 +5469,11 @@
           </a:fontRef>
         </p:style>
         <p:txBody>
-          <a:bodyPr rtlCol="0" anchor="ctr" lIns="182880" tIns="182880"/>
+          <a:bodyPr lIns="182880" tIns="182880" rtlCol="0" anchor="ctr"/>
           <a:lstStyle/>
           <a:p>
             <a:pPr algn="ctr">
-              <a:defRPr b="1" sz="1600">
+              <a:defRPr sz="1600" b="1">
                 <a:solidFill>
                   <a:srgbClr val="C8102E"/>
                 </a:solidFill>
@@ -5288,11 +5535,11 @@
           </a:fontRef>
         </p:style>
         <p:txBody>
-          <a:bodyPr rtlCol="0" anchor="ctr" lIns="182880" tIns="182880"/>
+          <a:bodyPr lIns="182880" tIns="182880" rtlCol="0" anchor="ctr"/>
           <a:lstStyle/>
           <a:p>
             <a:pPr algn="ctr">
-              <a:defRPr b="1" sz="1600">
+              <a:defRPr sz="1600" b="1">
                 <a:solidFill>
                   <a:srgbClr val="C8102E"/>
                 </a:solidFill>
@@ -5354,11 +5601,11 @@
           </a:fontRef>
         </p:style>
         <p:txBody>
-          <a:bodyPr rtlCol="0" anchor="ctr" lIns="182880" tIns="182880"/>
+          <a:bodyPr lIns="182880" tIns="182880" rtlCol="0" anchor="ctr"/>
           <a:lstStyle/>
           <a:p>
             <a:pPr algn="ctr">
-              <a:defRPr b="1" sz="1600">
+              <a:defRPr sz="1600" b="1">
                 <a:solidFill>
                   <a:srgbClr val="C8102E"/>
                 </a:solidFill>
@@ -5420,11 +5667,11 @@
           </a:fontRef>
         </p:style>
         <p:txBody>
-          <a:bodyPr rtlCol="0" anchor="ctr" lIns="182880" tIns="182880"/>
+          <a:bodyPr lIns="182880" tIns="182880" rtlCol="0" anchor="ctr"/>
           <a:lstStyle/>
           <a:p>
             <a:pPr algn="ctr">
-              <a:defRPr b="1" sz="1600">
+              <a:defRPr sz="1600" b="1">
                 <a:solidFill>
                   <a:srgbClr val="C8102E"/>
                 </a:solidFill>
@@ -5486,11 +5733,11 @@
           </a:fontRef>
         </p:style>
         <p:txBody>
-          <a:bodyPr rtlCol="0" anchor="ctr" lIns="182880" tIns="182880"/>
+          <a:bodyPr lIns="182880" tIns="182880" rtlCol="0" anchor="ctr"/>
           <a:lstStyle/>
           <a:p>
             <a:pPr algn="ctr">
-              <a:defRPr b="1" sz="1600">
+              <a:defRPr sz="1600" b="1">
                 <a:solidFill>
                   <a:srgbClr val="C8102E"/>
                 </a:solidFill>
@@ -5523,7 +5770,7 @@
 </file>
 
 <file path=ppt/slides/slide7.xml><?xml version="1.0" encoding="utf-8"?>
-<p:sld xmlns:a="http://schemas.openxmlformats.org/drawingml/2006/main" xmlns:p="http://schemas.openxmlformats.org/presentationml/2006/main" xmlns:r="http://schemas.openxmlformats.org/officeDocument/2006/relationships">
+<p:sld xmlns:a="http://schemas.openxmlformats.org/drawingml/2006/main" xmlns:r="http://schemas.openxmlformats.org/officeDocument/2006/relationships" xmlns:p="http://schemas.openxmlformats.org/presentationml/2006/main">
   <p:cSld>
     <p:spTree>
       <p:nvGrpSpPr>
@@ -5531,7 +5778,14 @@
         <p:cNvGrpSpPr/>
         <p:nvPr/>
       </p:nvGrpSpPr>
-      <p:grpSpPr/>
+      <p:grpSpPr>
+        <a:xfrm>
+          <a:off x="0" y="0"/>
+          <a:ext cx="0" cy="0"/>
+          <a:chOff x="0" y="0"/>
+          <a:chExt cx="0" cy="0"/>
+        </a:xfrm>
+      </p:grpSpPr>
       <p:sp>
         <p:nvSpPr>
           <p:cNvPr id="2" name="Rectangle 1"/>
@@ -5570,7 +5824,7 @@
           </a:fontRef>
         </p:style>
         <p:txBody>
-          <a:bodyPr rtlCol="0" anchor="ctr" wrap="square" lIns="457200" tIns="228600"/>
+          <a:bodyPr wrap="square" lIns="457200" tIns="228600" rtlCol="0" anchor="ctr"/>
           <a:lstStyle/>
           <a:p>
             <a:pPr algn="l">
@@ -5628,6 +5882,7 @@
           <a:lstStyle/>
           <a:p>
             <a:pPr algn="ctr"/>
+            <a:endParaRPr/>
           </a:p>
         </p:txBody>
       </p:sp>
@@ -5669,11 +5924,11 @@
           </a:fontRef>
         </p:style>
         <p:txBody>
-          <a:bodyPr rtlCol="0" anchor="ctr" lIns="274320" tIns="182880"/>
+          <a:bodyPr lIns="274320" tIns="182880" rtlCol="0" anchor="ctr"/>
           <a:lstStyle/>
           <a:p>
             <a:pPr algn="ctr">
-              <a:defRPr b="1" sz="1600">
+              <a:defRPr sz="1600" b="1">
                 <a:solidFill>
                   <a:srgbClr val="06B6D4"/>
                 </a:solidFill>
@@ -5735,11 +5990,11 @@
           </a:fontRef>
         </p:style>
         <p:txBody>
-          <a:bodyPr rtlCol="0" anchor="ctr" lIns="274320" tIns="182880"/>
+          <a:bodyPr lIns="274320" tIns="182880" rtlCol="0" anchor="ctr"/>
           <a:lstStyle/>
           <a:p>
             <a:pPr algn="ctr">
-              <a:defRPr b="1" sz="1600">
+              <a:defRPr sz="1600" b="1">
                 <a:solidFill>
                   <a:srgbClr val="06B6D4"/>
                 </a:solidFill>
@@ -5801,11 +6056,11 @@
           </a:fontRef>
         </p:style>
         <p:txBody>
-          <a:bodyPr rtlCol="0" anchor="ctr" lIns="274320" tIns="182880"/>
+          <a:bodyPr lIns="274320" tIns="182880" rtlCol="0" anchor="ctr"/>
           <a:lstStyle/>
           <a:p>
             <a:pPr algn="ctr">
-              <a:defRPr b="1" sz="1600">
+              <a:defRPr sz="1600" b="1">
                 <a:solidFill>
                   <a:srgbClr val="06B6D4"/>
                 </a:solidFill>
@@ -5867,11 +6122,11 @@
           </a:fontRef>
         </p:style>
         <p:txBody>
-          <a:bodyPr rtlCol="0" anchor="ctr" lIns="274320" tIns="182880"/>
+          <a:bodyPr lIns="274320" tIns="182880" rtlCol="0" anchor="ctr"/>
           <a:lstStyle/>
           <a:p>
             <a:pPr algn="ctr">
-              <a:defRPr b="1" sz="1600">
+              <a:defRPr sz="1600" b="1">
                 <a:solidFill>
                   <a:srgbClr val="06B6D4"/>
                 </a:solidFill>
@@ -5904,7 +6159,7 @@
 </file>
 
 <file path=ppt/slides/slide8.xml><?xml version="1.0" encoding="utf-8"?>
-<p:sld xmlns:a="http://schemas.openxmlformats.org/drawingml/2006/main" xmlns:p="http://schemas.openxmlformats.org/presentationml/2006/main" xmlns:r="http://schemas.openxmlformats.org/officeDocument/2006/relationships">
+<p:sld xmlns:a="http://schemas.openxmlformats.org/drawingml/2006/main" xmlns:r="http://schemas.openxmlformats.org/officeDocument/2006/relationships" xmlns:p="http://schemas.openxmlformats.org/presentationml/2006/main">
   <p:cSld>
     <p:spTree>
       <p:nvGrpSpPr>
@@ -5912,7 +6167,14 @@
         <p:cNvGrpSpPr/>
         <p:nvPr/>
       </p:nvGrpSpPr>
-      <p:grpSpPr/>
+      <p:grpSpPr>
+        <a:xfrm>
+          <a:off x="0" y="0"/>
+          <a:ext cx="0" cy="0"/>
+          <a:chOff x="0" y="0"/>
+          <a:chExt cx="0" cy="0"/>
+        </a:xfrm>
+      </p:grpSpPr>
       <p:sp>
         <p:nvSpPr>
           <p:cNvPr id="2" name="Rectangle 1"/>
@@ -5951,7 +6213,7 @@
           </a:fontRef>
         </p:style>
         <p:txBody>
-          <a:bodyPr rtlCol="0" anchor="ctr" wrap="square" lIns="457200" tIns="228600"/>
+          <a:bodyPr wrap="square" lIns="457200" tIns="228600" rtlCol="0" anchor="ctr"/>
           <a:lstStyle/>
           <a:p>
             <a:pPr algn="l">
@@ -6009,6 +6271,7 @@
           <a:lstStyle/>
           <a:p>
             <a:pPr algn="ctr"/>
+            <a:endParaRPr/>
           </a:p>
         </p:txBody>
       </p:sp>
@@ -6050,14 +6313,15 @@
           </a:fontRef>
         </p:style>
         <p:txBody>
-          <a:bodyPr rtlCol="0" anchor="ctr" lIns="365760" tIns="365760"/>
+          <a:bodyPr lIns="365760" tIns="365760" rtlCol="0" anchor="ctr"/>
           <a:lstStyle/>
           <a:p>
             <a:pPr algn="ctr"/>
+            <a:endParaRPr/>
           </a:p>
           <a:p>
             <a:pPr>
-              <a:defRPr b="1" sz="1500">
+              <a:defRPr sz="1500" b="1">
                 <a:solidFill>
                   <a:srgbClr val="C8102E"/>
                 </a:solidFill>
@@ -6075,10 +6339,16 @@
               <a:t>Query tool strictly validates SELECT statements, preventing any unauthorized INSERT, UPDATE, DELETE, or DROP database operations.</a:t>
             </a:r>
           </a:p>
-          <a:p/>
+          <a:p>
+            <a:endParaRPr b="0">
+              <a:solidFill>
+                <a:srgbClr val="0F172A"/>
+              </a:solidFill>
+            </a:endParaRPr>
+          </a:p>
           <a:p>
             <a:pPr>
-              <a:defRPr b="1" sz="1500">
+              <a:defRPr sz="1500" b="1">
                 <a:solidFill>
                   <a:srgbClr val="C8102E"/>
                 </a:solidFill>
@@ -6096,10 +6366,16 @@
               <a:t>Full token verification with JWT session management and unstructured login audit logging (login_logs).</a:t>
             </a:r>
           </a:p>
-          <a:p/>
+          <a:p>
+            <a:endParaRPr b="0">
+              <a:solidFill>
+                <a:srgbClr val="0F172A"/>
+              </a:solidFill>
+            </a:endParaRPr>
+          </a:p>
           <a:p>
             <a:pPr>
-              <a:defRPr b="1" sz="1500">
+              <a:defRPr sz="1500" b="1">
                 <a:solidFill>
                   <a:srgbClr val="C8102E"/>
                 </a:solidFill>
@@ -6117,10 +6393,16 @@
               <a:t>100% test coverage across all 5 agent tool functions (python -m pytest backend/tests/test_tools.py passed 6/6 tests in 0.24s).</a:t>
             </a:r>
           </a:p>
-          <a:p/>
+          <a:p>
+            <a:endParaRPr b="0">
+              <a:solidFill>
+                <a:srgbClr val="0F172A"/>
+              </a:solidFill>
+            </a:endParaRPr>
+          </a:p>
           <a:p>
             <a:pPr>
-              <a:defRPr b="1" sz="1500">
+              <a:defRPr sz="1500" b="1">
                 <a:solidFill>
                   <a:srgbClr val="C8102E"/>
                 </a:solidFill>
@@ -6138,7 +6420,13 @@
               <a:t>Includes production-ready Dockerfile and docker-compose.yml for easy containerized deployment.</a:t>
             </a:r>
           </a:p>
-          <a:p/>
+          <a:p>
+            <a:endParaRPr b="0">
+              <a:solidFill>
+                <a:srgbClr val="0F172A"/>
+              </a:solidFill>
+            </a:endParaRPr>
+          </a:p>
         </p:txBody>
       </p:sp>
     </p:spTree>
@@ -6150,7 +6438,7 @@
 </file>
 
 <file path=ppt/slides/slide9.xml><?xml version="1.0" encoding="utf-8"?>
-<p:sld xmlns:a="http://schemas.openxmlformats.org/drawingml/2006/main" xmlns:p="http://schemas.openxmlformats.org/presentationml/2006/main" xmlns:r="http://schemas.openxmlformats.org/officeDocument/2006/relationships">
+<p:sld xmlns:a="http://schemas.openxmlformats.org/drawingml/2006/main" xmlns:r="http://schemas.openxmlformats.org/officeDocument/2006/relationships" xmlns:p="http://schemas.openxmlformats.org/presentationml/2006/main">
   <p:cSld>
     <p:spTree>
       <p:nvGrpSpPr>
@@ -6158,7 +6446,14 @@
         <p:cNvGrpSpPr/>
         <p:nvPr/>
       </p:nvGrpSpPr>
-      <p:grpSpPr/>
+      <p:grpSpPr>
+        <a:xfrm>
+          <a:off x="0" y="0"/>
+          <a:ext cx="0" cy="0"/>
+          <a:chOff x="0" y="0"/>
+          <a:chExt cx="0" cy="0"/>
+        </a:xfrm>
+      </p:grpSpPr>
       <p:sp>
         <p:nvSpPr>
           <p:cNvPr id="2" name="Rectangle 1"/>
@@ -6197,7 +6492,7 @@
           </a:fontRef>
         </p:style>
         <p:txBody>
-          <a:bodyPr rtlCol="0" anchor="ctr" wrap="square" lIns="457200" tIns="228600"/>
+          <a:bodyPr wrap="square" lIns="457200" tIns="228600" rtlCol="0" anchor="ctr"/>
           <a:lstStyle/>
           <a:p>
             <a:pPr algn="l">
@@ -6208,6 +6503,7 @@
               </a:defRPr>
             </a:pPr>
             <a:r>
+              <a:rPr lang="en-US" noProof="0" dirty="0"/>
               <a:t>IMPACT AND BENEFITS</a:t>
             </a:r>
           </a:p>
@@ -6255,6 +6551,7 @@
           <a:lstStyle/>
           <a:p>
             <a:pPr algn="ctr"/>
+            <a:endParaRPr lang="en-US" noProof="0" dirty="0"/>
           </a:p>
         </p:txBody>
       </p:sp>
@@ -6296,30 +6593,31 @@
           </a:fontRef>
         </p:style>
         <p:txBody>
-          <a:bodyPr rtlCol="0" anchor="ctr" lIns="274320" tIns="365760"/>
+          <a:bodyPr lIns="274320" tIns="365760" rtlCol="0" anchor="ctr"/>
           <a:lstStyle/>
           <a:p>
             <a:pPr algn="ctr">
-              <a:defRPr b="1" sz="1800">
+              <a:defRPr sz="1800" b="1">
                 <a:solidFill>
                   <a:srgbClr val="C8102E"/>
                 </a:solidFill>
               </a:defRPr>
             </a:pPr>
             <a:r>
+              <a:rPr lang="en-US" noProof="0" dirty="0"/>
               <a:t>SOCIAL IMPACT</a:t>
             </a:r>
           </a:p>
           <a:p>
-            <a:br/>
-            <a:pPr>
-              <a:defRPr sz="1400">
-                <a:solidFill>
-                  <a:srgbClr val="0F172A"/>
-                </a:solidFill>
-              </a:defRPr>
-            </a:pPr>
-            <a:r>
+            <a:br>
+              <a:rPr lang="en-US" noProof="0" dirty="0"/>
+            </a:br>
+            <a:r>
+              <a:rPr lang="en-US" noProof="0" dirty="0">
+                <a:solidFill>
+                  <a:srgbClr val="FF0000"/>
+                </a:solidFill>
+              </a:rPr>
               <a:t>Democratizes data analytics for non-technical employees, breaking down technological barriers.</a:t>
             </a:r>
           </a:p>
@@ -6363,30 +6661,27 @@
           </a:fontRef>
         </p:style>
         <p:txBody>
-          <a:bodyPr rtlCol="0" anchor="ctr" lIns="274320" tIns="365760"/>
+          <a:bodyPr lIns="274320" tIns="365760" rtlCol="0" anchor="ctr"/>
           <a:lstStyle/>
           <a:p>
             <a:pPr algn="ctr">
-              <a:defRPr b="1" sz="1800">
+              <a:defRPr sz="1800" b="1">
                 <a:solidFill>
                   <a:srgbClr val="06B6D4"/>
                 </a:solidFill>
               </a:defRPr>
             </a:pPr>
             <a:r>
+              <a:rPr lang="en-US" noProof="0" dirty="0"/>
               <a:t>ECONOMIC IMPACT</a:t>
             </a:r>
           </a:p>
           <a:p>
-            <a:br/>
-            <a:pPr>
-              <a:defRPr sz="1400">
-                <a:solidFill>
-                  <a:srgbClr val="FFFFFF"/>
-                </a:solidFill>
-              </a:defRPr>
-            </a:pPr>
-            <a:r>
+            <a:br>
+              <a:rPr lang="en-US" noProof="0" dirty="0"/>
+            </a:br>
+            <a:r>
+              <a:rPr lang="en-US" noProof="0" dirty="0"/>
               <a:t>Reduces custom BI dashboard development costs by over 80% and slashes report turnaround from days to seconds.</a:t>
             </a:r>
           </a:p>
@@ -6430,30 +6725,31 @@
           </a:fontRef>
         </p:style>
         <p:txBody>
-          <a:bodyPr rtlCol="0" anchor="ctr" lIns="274320" tIns="365760"/>
+          <a:bodyPr lIns="274320" tIns="365760" rtlCol="0" anchor="ctr"/>
           <a:lstStyle/>
           <a:p>
             <a:pPr algn="ctr">
-              <a:defRPr b="1" sz="1800">
+              <a:defRPr sz="1800" b="1">
                 <a:solidFill>
                   <a:srgbClr val="C8102E"/>
                 </a:solidFill>
               </a:defRPr>
             </a:pPr>
             <a:r>
+              <a:rPr lang="en-US" noProof="0" dirty="0"/>
               <a:t>TECHNICAL IMPACT</a:t>
             </a:r>
           </a:p>
           <a:p>
-            <a:br/>
-            <a:pPr>
-              <a:defRPr sz="1400">
-                <a:solidFill>
-                  <a:srgbClr val="0F172A"/>
-                </a:solidFill>
-              </a:defRPr>
-            </a:pPr>
-            <a:r>
+            <a:br>
+              <a:rPr lang="en-US" noProof="0" dirty="0"/>
+            </a:br>
+            <a:r>
+              <a:rPr lang="en-US" noProof="0" dirty="0">
+                <a:solidFill>
+                  <a:srgbClr val="FF0000"/>
+                </a:solidFill>
+              </a:rPr>
               <a:t>Provides full SQL transparency, query timing, multi-database adaptability, and audit logging.</a:t>
             </a:r>
           </a:p>

</xml_diff>